<commit_message>
Corrige renumeracao MEP 30/40 e peso 24kg em todo o projeto
Site (25kg->24kg + bug de calculo no chatbot), CSV da loja (MEP30
Encunhamento sem preco + MEP40 Reboco Fino R$130) e apresentacao
(deck agora com 8 slides, MEP30=Encunhamento e MEP40=Reboco Fino,
PDF/PPTX regenerados). Confirmado pelo cliente em 21/07.

Co-Authored-By: Claude Sonnet 5 <noreply@anthropic.com>
</commit_message>
<xml_diff>
--- a/marketing/Manual-Tecnico-MEP.pptx
+++ b/marketing/Manual-Tecnico-MEP.pptx
@@ -12,8 +12,9 @@
     <p:sldId id="260" r:id="rId11"/>
     <p:sldId id="261" r:id="rId12"/>
     <p:sldId id="262" r:id="rId13"/>
+    <p:sldId id="263" r:id="rId14"/>
   </p:sldIdLst>
-  <p:sldSz cx="12192000" cy="6858000" type="screen4x3"/>
+  <p:sldSz cx="12191695" cy="6858000" type="screen4x3"/>
   <p:notesSz cx="6858000" cy="9144000"/>
   <p:defaultTextStyle>
     <a:defPPr>
@@ -3111,7 +3112,7 @@
         <p:spPr>
           <a:xfrm>
             <a:off x="0" y="0"/>
-            <a:ext cx="12192000" cy="6858000"/>
+            <a:ext cx="12191695" cy="6858000"/>
           </a:xfrm>
           <a:prstGeom prst="rect">
             <a:avLst/>
@@ -3153,7 +3154,7 @@
         <p:spPr>
           <a:xfrm>
             <a:off x="0" y="0"/>
-            <a:ext cx="12192000" cy="6858000"/>
+            <a:ext cx="12191695" cy="6858000"/>
           </a:xfrm>
           <a:prstGeom prst="rect">
             <a:avLst/>
@@ -3195,7 +3196,7 @@
         <p:spPr>
           <a:xfrm>
             <a:off x="0" y="0"/>
-            <a:ext cx="12192000" cy="6858000"/>
+            <a:ext cx="12191695" cy="6858000"/>
           </a:xfrm>
           <a:prstGeom prst="rect">
             <a:avLst/>
@@ -3237,7 +3238,7 @@
         <p:spPr>
           <a:xfrm>
             <a:off x="0" y="0"/>
-            <a:ext cx="12192000" cy="6858000"/>
+            <a:ext cx="12191695" cy="6858000"/>
           </a:xfrm>
           <a:prstGeom prst="rect">
             <a:avLst/>
@@ -3279,7 +3280,7 @@
         <p:spPr>
           <a:xfrm>
             <a:off x="0" y="0"/>
-            <a:ext cx="12192000" cy="6858000"/>
+            <a:ext cx="12191695" cy="6858000"/>
           </a:xfrm>
           <a:prstGeom prst="rect">
             <a:avLst/>
@@ -3306,7 +3307,7 @@
       <p:grpSpPr/>
       <p:pic>
         <p:nvPicPr>
-          <p:cNvPr id="2" name="Picture 1" descr="slide-06-consumo.png"/>
+          <p:cNvPr id="2" name="Picture 1" descr="slide-06-mep40.png"/>
           <p:cNvPicPr>
             <a:picLocks noChangeAspect="1"/>
           </p:cNvPicPr>
@@ -3321,7 +3322,7 @@
         <p:spPr>
           <a:xfrm>
             <a:off x="0" y="0"/>
-            <a:ext cx="12192000" cy="6858000"/>
+            <a:ext cx="12191695" cy="6858000"/>
           </a:xfrm>
           <a:prstGeom prst="rect">
             <a:avLst/>
@@ -3348,7 +3349,7 @@
       <p:grpSpPr/>
       <p:pic>
         <p:nvPicPr>
-          <p:cNvPr id="2" name="Picture 1" descr="slide-07-contato.png"/>
+          <p:cNvPr id="2" name="Picture 1" descr="slide-07-consumo.png"/>
           <p:cNvPicPr>
             <a:picLocks noChangeAspect="1"/>
           </p:cNvPicPr>
@@ -3363,7 +3364,49 @@
         <p:spPr>
           <a:xfrm>
             <a:off x="0" y="0"/>
-            <a:ext cx="12192000" cy="6858000"/>
+            <a:ext cx="12191695" cy="6858000"/>
+          </a:xfrm>
+          <a:prstGeom prst="rect">
+            <a:avLst/>
+          </a:prstGeom>
+        </p:spPr>
+      </p:pic>
+    </p:spTree>
+  </p:cSld>
+  <p:clrMapOvr>
+    <a:masterClrMapping/>
+  </p:clrMapOvr>
+</p:sld>
+</file>
+
+<file path=ppt/slides/slide8.xml><?xml version="1.0" encoding="utf-8"?>
+<p:sld xmlns:a="http://schemas.openxmlformats.org/drawingml/2006/main" xmlns:p="http://schemas.openxmlformats.org/presentationml/2006/main" xmlns:r="http://schemas.openxmlformats.org/officeDocument/2006/relationships">
+  <p:cSld>
+    <p:spTree>
+      <p:nvGrpSpPr>
+        <p:cNvPr id="1" name=""/>
+        <p:cNvGrpSpPr/>
+        <p:nvPr/>
+      </p:nvGrpSpPr>
+      <p:grpSpPr/>
+      <p:pic>
+        <p:nvPicPr>
+          <p:cNvPr id="2" name="Picture 1" descr="slide-08-contato.png"/>
+          <p:cNvPicPr>
+            <a:picLocks noChangeAspect="1"/>
+          </p:cNvPicPr>
+          <p:nvPr/>
+        </p:nvPicPr>
+        <p:blipFill>
+          <a:blip r:embed="rId2"/>
+          <a:stretch>
+            <a:fillRect/>
+          </a:stretch>
+        </p:blipFill>
+        <p:spPr>
+          <a:xfrm>
+            <a:off x="0" y="0"/>
+            <a:ext cx="12191695" cy="6858000"/>
           </a:xfrm>
           <a:prstGeom prst="rect">
             <a:avLst/>

</xml_diff>